<commit_message>
Add manual deployment evaluation pipeline and simplify judges
Use OIDC for app-only deployment, wait for complete evaluation results, and report quality scores without a release threshold. Use latest agent and evaluator versions, clarify the judges, and document optimisation observability. Grant project identity access to its project and traces in companion Bicep; include the updated presentation.

Co-authored-by: Copilot <223556219+Copilot@users.noreply.github.com>
Copilot-Session: bf15ab1d-7ffc-4402-bc46-09d109387980
</commit_message>
<xml_diff>
--- a/presentation/presentation.pptx
+++ b/presentation/presentation.pptx
@@ -211,7 +211,7 @@
           <a:p>
             <a:fld id="{5282F153-3F37-0F45-9E97-73ACFA13230C}" type="datetimeFigureOut">
               <a:rPr lang="en-US"/>
-              <a:t>9/24/26</a:t>
+              <a:t>10/9/26</a:t>
             </a:fld>
             <a:endParaRPr lang="en-US"/>
           </a:p>
@@ -3108,123 +3108,6 @@
       </p:sp>
       <p:sp>
         <p:nvSpPr>
-          <p:cNvPr id="5" name="static:3:text"/>
-          <p:cNvSpPr/>
-          <p:nvPr/>
-        </p:nvSpPr>
-        <p:spPr>
-          <a:xfrm>
-            <a:off x="975360" y="3895130"/>
-            <a:ext cx="3240524" cy="259080"/>
-          </a:xfrm>
-          <a:prstGeom prst="rect">
-            <a:avLst/>
-          </a:prstGeom>
-          <a:noFill/>
-          <a:ln/>
-        </p:spPr>
-        <p:txBody>
-          <a:bodyPr wrap="none" lIns="0" tIns="0" rIns="0" bIns="0" rtlCol="0" anchor="ctr"/>
-          <a:lstStyle/>
-          <a:p>
-            <a:pPr marL="0" indent="0" algn="l">
-              <a:buNone/>
-            </a:pPr>
-            <a:r>
-              <a:rPr lang="en-US" sz="1620" dirty="0">
-                <a:solidFill>
-                  <a:srgbClr val="B0B0B0"/>
-                </a:solidFill>
-                <a:latin typeface="Arial" pitchFamily="34" charset="0"/>
-                <a:ea typeface="Arial" pitchFamily="34" charset="-122"/>
-                <a:cs typeface="Arial" pitchFamily="34" charset="-120"/>
-              </a:rPr>
-              <a:t>Start with a working agent. Measure</a:t>
-            </a:r>
-            <a:endParaRPr lang="en-US" sz="1620" dirty="0"/>
-          </a:p>
-        </p:txBody>
-      </p:sp>
-      <p:sp>
-        <p:nvSpPr>
-          <p:cNvPr id="6" name="static:4:text"/>
-          <p:cNvSpPr/>
-          <p:nvPr/>
-        </p:nvSpPr>
-        <p:spPr>
-          <a:xfrm>
-            <a:off x="975360" y="4172783"/>
-            <a:ext cx="3783806" cy="259080"/>
-          </a:xfrm>
-          <a:prstGeom prst="rect">
-            <a:avLst/>
-          </a:prstGeom>
-          <a:noFill/>
-          <a:ln/>
-        </p:spPr>
-        <p:txBody>
-          <a:bodyPr wrap="none" lIns="0" tIns="0" rIns="0" bIns="0" rtlCol="0" anchor="ctr"/>
-          <a:lstStyle/>
-          <a:p>
-            <a:pPr marL="0" indent="0" algn="l">
-              <a:buNone/>
-            </a:pPr>
-            <a:r>
-              <a:rPr lang="en-US" sz="1620" dirty="0">
-                <a:solidFill>
-                  <a:srgbClr val="B0B0B0"/>
-                </a:solidFill>
-                <a:latin typeface="Arial" pitchFamily="34" charset="0"/>
-                <a:ea typeface="Arial" pitchFamily="34" charset="-122"/>
-                <a:cs typeface="Arial" pitchFamily="34" charset="-120"/>
-              </a:rPr>
-              <a:t>consistency, speed and cost. Improve with</a:t>
-            </a:r>
-            <a:endParaRPr lang="en-US" sz="1620" dirty="0"/>
-          </a:p>
-        </p:txBody>
-      </p:sp>
-      <p:sp>
-        <p:nvSpPr>
-          <p:cNvPr id="7" name="static:5:text"/>
-          <p:cNvSpPr/>
-          <p:nvPr/>
-        </p:nvSpPr>
-        <p:spPr>
-          <a:xfrm>
-            <a:off x="975360" y="4450437"/>
-            <a:ext cx="940594" cy="259080"/>
-          </a:xfrm>
-          <a:prstGeom prst="rect">
-            <a:avLst/>
-          </a:prstGeom>
-          <a:noFill/>
-          <a:ln/>
-        </p:spPr>
-        <p:txBody>
-          <a:bodyPr wrap="none" lIns="0" tIns="0" rIns="0" bIns="0" rtlCol="0" anchor="ctr"/>
-          <a:lstStyle/>
-          <a:p>
-            <a:pPr marL="0" indent="0" algn="l">
-              <a:buNone/>
-            </a:pPr>
-            <a:r>
-              <a:rPr lang="en-US" sz="1620" dirty="0">
-                <a:solidFill>
-                  <a:srgbClr val="B0B0B0"/>
-                </a:solidFill>
-                <a:latin typeface="Arial" pitchFamily="34" charset="0"/>
-                <a:ea typeface="Arial" pitchFamily="34" charset="-122"/>
-                <a:cs typeface="Arial" pitchFamily="34" charset="-120"/>
-              </a:rPr>
-              <a:t>evidence.</a:t>
-            </a:r>
-            <a:endParaRPr lang="en-US" sz="1620" dirty="0"/>
-          </a:p>
-        </p:txBody>
-      </p:sp>
-      <p:sp>
-        <p:nvSpPr>
           <p:cNvPr id="8" name="static:6:text"/>
           <p:cNvSpPr/>
           <p:nvPr/>
@@ -3259,454 +3142,6 @@
               <a:t>Graeme Foster</a:t>
             </a:r>
             <a:endParaRPr lang="en-US" sz="840" dirty="0"/>
-          </a:p>
-        </p:txBody>
-      </p:sp>
-      <p:sp>
-        <p:nvSpPr>
-          <p:cNvPr id="9" name="static:7:shape"/>
-          <p:cNvSpPr/>
-          <p:nvPr/>
-        </p:nvSpPr>
-        <p:spPr>
-          <a:xfrm>
-            <a:off x="6838355" y="2740104"/>
-            <a:ext cx="2143363" cy="899160"/>
-          </a:xfrm>
-          <a:prstGeom prst="roundRect">
-            <a:avLst>
-              <a:gd name="adj" fmla="val 13559"/>
-            </a:avLst>
-          </a:prstGeom>
-          <a:solidFill>
-            <a:srgbClr val="292929"/>
-          </a:solidFill>
-          <a:ln w="7620">
-            <a:solidFill>
-              <a:srgbClr val="474747"/>
-            </a:solidFill>
-            <a:prstDash val="solid"/>
-          </a:ln>
-        </p:spPr>
-        <p:txBody>
-          <a:bodyPr/>
-          <a:lstStyle/>
-          <a:p>
-            <a:endParaRPr lang="en-US"/>
-          </a:p>
-        </p:txBody>
-      </p:sp>
-      <p:sp>
-        <p:nvSpPr>
-          <p:cNvPr id="10" name="static:8:text"/>
-          <p:cNvSpPr/>
-          <p:nvPr/>
-        </p:nvSpPr>
-        <p:spPr>
-          <a:xfrm>
-            <a:off x="6983135" y="2877264"/>
-            <a:ext cx="660440" cy="190500"/>
-          </a:xfrm>
-          <a:prstGeom prst="rect">
-            <a:avLst/>
-          </a:prstGeom>
-          <a:noFill/>
-          <a:ln/>
-        </p:spPr>
-        <p:txBody>
-          <a:bodyPr wrap="none" lIns="0" tIns="0" rIns="0" bIns="0" rtlCol="0" anchor="ctr"/>
-          <a:lstStyle/>
-          <a:p>
-            <a:pPr marL="0" indent="0" algn="l">
-              <a:buNone/>
-            </a:pPr>
-            <a:r>
-              <a:rPr lang="en-US" sz="1200" b="1" dirty="0">
-                <a:solidFill>
-                  <a:srgbClr val="FBBF24"/>
-                </a:solidFill>
-                <a:latin typeface="Arial" pitchFamily="34" charset="0"/>
-                <a:ea typeface="Arial" pitchFamily="34" charset="-122"/>
-                <a:cs typeface="Arial" pitchFamily="34" charset="-120"/>
-              </a:rPr>
-              <a:t>Context</a:t>
-            </a:r>
-            <a:endParaRPr lang="en-US" sz="1200" dirty="0"/>
-          </a:p>
-        </p:txBody>
-      </p:sp>
-      <p:sp>
-        <p:nvSpPr>
-          <p:cNvPr id="11" name="static:9:text"/>
-          <p:cNvSpPr/>
-          <p:nvPr/>
-        </p:nvSpPr>
-        <p:spPr>
-          <a:xfrm>
-            <a:off x="6983135" y="3113484"/>
-            <a:ext cx="769739" cy="152400"/>
-          </a:xfrm>
-          <a:prstGeom prst="rect">
-            <a:avLst/>
-          </a:prstGeom>
-          <a:noFill/>
-          <a:ln/>
-        </p:spPr>
-        <p:txBody>
-          <a:bodyPr wrap="none" lIns="0" tIns="0" rIns="0" bIns="0" rtlCol="0" anchor="ctr"/>
-          <a:lstStyle/>
-          <a:p>
-            <a:pPr marL="0" indent="0" algn="l">
-              <a:buNone/>
-            </a:pPr>
-            <a:r>
-              <a:rPr lang="en-US" sz="960" dirty="0">
-                <a:solidFill>
-                  <a:srgbClr val="DEDEDE"/>
-                </a:solidFill>
-                <a:latin typeface="Arial" pitchFamily="34" charset="0"/>
-                <a:ea typeface="Arial" pitchFamily="34" charset="-122"/>
-                <a:cs typeface="Arial" pitchFamily="34" charset="-120"/>
-              </a:rPr>
-              <a:t>Microsoft IQ</a:t>
-            </a:r>
-            <a:endParaRPr lang="en-US" sz="960" dirty="0"/>
-          </a:p>
-        </p:txBody>
-      </p:sp>
-      <p:sp>
-        <p:nvSpPr>
-          <p:cNvPr id="12" name="static:10:shape"/>
-          <p:cNvSpPr/>
-          <p:nvPr/>
-        </p:nvSpPr>
-        <p:spPr>
-          <a:xfrm>
-            <a:off x="9073158" y="2740104"/>
-            <a:ext cx="2143482" cy="899160"/>
-          </a:xfrm>
-          <a:prstGeom prst="roundRect">
-            <a:avLst>
-              <a:gd name="adj" fmla="val 13559"/>
-            </a:avLst>
-          </a:prstGeom>
-          <a:solidFill>
-            <a:srgbClr val="292929"/>
-          </a:solidFill>
-          <a:ln w="7620">
-            <a:solidFill>
-              <a:srgbClr val="474747"/>
-            </a:solidFill>
-            <a:prstDash val="solid"/>
-          </a:ln>
-        </p:spPr>
-        <p:txBody>
-          <a:bodyPr/>
-          <a:lstStyle/>
-          <a:p>
-            <a:endParaRPr lang="en-US"/>
-          </a:p>
-        </p:txBody>
-      </p:sp>
-      <p:sp>
-        <p:nvSpPr>
-          <p:cNvPr id="13" name="static:11:text"/>
-          <p:cNvSpPr/>
-          <p:nvPr/>
-        </p:nvSpPr>
-        <p:spPr>
-          <a:xfrm>
-            <a:off x="9217938" y="2877264"/>
-            <a:ext cx="837486" cy="190500"/>
-          </a:xfrm>
-          <a:prstGeom prst="rect">
-            <a:avLst/>
-          </a:prstGeom>
-          <a:noFill/>
-          <a:ln/>
-        </p:spPr>
-        <p:txBody>
-          <a:bodyPr wrap="none" lIns="0" tIns="0" rIns="0" bIns="0" rtlCol="0" anchor="ctr"/>
-          <a:lstStyle/>
-          <a:p>
-            <a:pPr marL="0" indent="0" algn="l">
-              <a:buNone/>
-            </a:pPr>
-            <a:r>
-              <a:rPr lang="en-US" sz="1200" b="1" dirty="0">
-                <a:solidFill>
-                  <a:srgbClr val="FBBF24"/>
-                </a:solidFill>
-                <a:latin typeface="Arial" pitchFamily="34" charset="0"/>
-                <a:ea typeface="Arial" pitchFamily="34" charset="-122"/>
-                <a:cs typeface="Arial" pitchFamily="34" charset="-120"/>
-              </a:rPr>
-              <a:t>Evaluation</a:t>
-            </a:r>
-            <a:endParaRPr lang="en-US" sz="1200" dirty="0"/>
-          </a:p>
-        </p:txBody>
-      </p:sp>
-      <p:sp>
-        <p:nvSpPr>
-          <p:cNvPr id="14" name="static:12:text"/>
-          <p:cNvSpPr/>
-          <p:nvPr/>
-        </p:nvSpPr>
-        <p:spPr>
-          <a:xfrm>
-            <a:off x="9217938" y="3113484"/>
-            <a:ext cx="1409105" cy="152400"/>
-          </a:xfrm>
-          <a:prstGeom prst="rect">
-            <a:avLst/>
-          </a:prstGeom>
-          <a:noFill/>
-          <a:ln/>
-        </p:spPr>
-        <p:txBody>
-          <a:bodyPr wrap="none" lIns="0" tIns="0" rIns="0" bIns="0" rtlCol="0" anchor="ctr"/>
-          <a:lstStyle/>
-          <a:p>
-            <a:pPr marL="0" indent="0" algn="l">
-              <a:buNone/>
-            </a:pPr>
-            <a:r>
-              <a:rPr lang="en-US" sz="960" dirty="0">
-                <a:solidFill>
-                  <a:srgbClr val="DEDEDE"/>
-                </a:solidFill>
-                <a:latin typeface="Arial" pitchFamily="34" charset="0"/>
-                <a:ea typeface="Arial" pitchFamily="34" charset="-122"/>
-                <a:cs typeface="Arial" pitchFamily="34" charset="-120"/>
-              </a:rPr>
-              <a:t>Evaluations + checklists</a:t>
-            </a:r>
-            <a:endParaRPr lang="en-US" sz="960" dirty="0"/>
-          </a:p>
-        </p:txBody>
-      </p:sp>
-      <p:sp>
-        <p:nvSpPr>
-          <p:cNvPr id="15" name="static:13:shape"/>
-          <p:cNvSpPr/>
-          <p:nvPr/>
-        </p:nvSpPr>
-        <p:spPr>
-          <a:xfrm>
-            <a:off x="6838355" y="3730704"/>
-            <a:ext cx="2143363" cy="899160"/>
-          </a:xfrm>
-          <a:prstGeom prst="roundRect">
-            <a:avLst>
-              <a:gd name="adj" fmla="val 13559"/>
-            </a:avLst>
-          </a:prstGeom>
-          <a:solidFill>
-            <a:srgbClr val="292929"/>
-          </a:solidFill>
-          <a:ln w="7620">
-            <a:solidFill>
-              <a:srgbClr val="474747"/>
-            </a:solidFill>
-            <a:prstDash val="solid"/>
-          </a:ln>
-        </p:spPr>
-        <p:txBody>
-          <a:bodyPr/>
-          <a:lstStyle/>
-          <a:p>
-            <a:endParaRPr lang="en-US"/>
-          </a:p>
-        </p:txBody>
-      </p:sp>
-      <p:sp>
-        <p:nvSpPr>
-          <p:cNvPr id="16" name="static:14:text"/>
-          <p:cNvSpPr/>
-          <p:nvPr/>
-        </p:nvSpPr>
-        <p:spPr>
-          <a:xfrm>
-            <a:off x="6983135" y="3867864"/>
-            <a:ext cx="1012507" cy="190500"/>
-          </a:xfrm>
-          <a:prstGeom prst="rect">
-            <a:avLst/>
-          </a:prstGeom>
-          <a:noFill/>
-          <a:ln/>
-        </p:spPr>
-        <p:txBody>
-          <a:bodyPr wrap="none" lIns="0" tIns="0" rIns="0" bIns="0" rtlCol="0" anchor="ctr"/>
-          <a:lstStyle/>
-          <a:p>
-            <a:pPr marL="0" indent="0" algn="l">
-              <a:buNone/>
-            </a:pPr>
-            <a:r>
-              <a:rPr lang="en-US" sz="1200" b="1" dirty="0">
-                <a:solidFill>
-                  <a:srgbClr val="FBBF24"/>
-                </a:solidFill>
-                <a:latin typeface="Arial" pitchFamily="34" charset="0"/>
-                <a:ea typeface="Arial" pitchFamily="34" charset="-122"/>
-                <a:cs typeface="Arial" pitchFamily="34" charset="-120"/>
-              </a:rPr>
-              <a:t>Optimisation</a:t>
-            </a:r>
-            <a:endParaRPr lang="en-US" sz="1200" dirty="0"/>
-          </a:p>
-        </p:txBody>
-      </p:sp>
-      <p:sp>
-        <p:nvSpPr>
-          <p:cNvPr id="17" name="static:15:text"/>
-          <p:cNvSpPr/>
-          <p:nvPr/>
-        </p:nvSpPr>
-        <p:spPr>
-          <a:xfrm>
-            <a:off x="6983135" y="4104084"/>
-            <a:ext cx="987147" cy="152400"/>
-          </a:xfrm>
-          <a:prstGeom prst="rect">
-            <a:avLst/>
-          </a:prstGeom>
-          <a:noFill/>
-          <a:ln/>
-        </p:spPr>
-        <p:txBody>
-          <a:bodyPr wrap="none" lIns="0" tIns="0" rIns="0" bIns="0" rtlCol="0" anchor="ctr"/>
-          <a:lstStyle/>
-          <a:p>
-            <a:pPr marL="0" indent="0" algn="l">
-              <a:buNone/>
-            </a:pPr>
-            <a:r>
-              <a:rPr lang="en-US" sz="960" dirty="0">
-                <a:solidFill>
-                  <a:srgbClr val="DEDEDE"/>
-                </a:solidFill>
-                <a:latin typeface="Arial" pitchFamily="34" charset="0"/>
-                <a:ea typeface="Arial" pitchFamily="34" charset="-122"/>
-                <a:cs typeface="Arial" pitchFamily="34" charset="-120"/>
-              </a:rPr>
-              <a:t>Agent Optimizer</a:t>
-            </a:r>
-            <a:endParaRPr lang="en-US" sz="960" dirty="0"/>
-          </a:p>
-        </p:txBody>
-      </p:sp>
-      <p:sp>
-        <p:nvSpPr>
-          <p:cNvPr id="18" name="static:16:shape"/>
-          <p:cNvSpPr/>
-          <p:nvPr/>
-        </p:nvSpPr>
-        <p:spPr>
-          <a:xfrm>
-            <a:off x="9073158" y="3730704"/>
-            <a:ext cx="2143482" cy="899160"/>
-          </a:xfrm>
-          <a:prstGeom prst="roundRect">
-            <a:avLst>
-              <a:gd name="adj" fmla="val 13559"/>
-            </a:avLst>
-          </a:prstGeom>
-          <a:solidFill>
-            <a:srgbClr val="292929"/>
-          </a:solidFill>
-          <a:ln w="7620">
-            <a:solidFill>
-              <a:srgbClr val="474747"/>
-            </a:solidFill>
-            <a:prstDash val="solid"/>
-          </a:ln>
-        </p:spPr>
-        <p:txBody>
-          <a:bodyPr/>
-          <a:lstStyle/>
-          <a:p>
-            <a:endParaRPr lang="en-US"/>
-          </a:p>
-        </p:txBody>
-      </p:sp>
-      <p:sp>
-        <p:nvSpPr>
-          <p:cNvPr id="19" name="static:17:text"/>
-          <p:cNvSpPr/>
-          <p:nvPr/>
-        </p:nvSpPr>
-        <p:spPr>
-          <a:xfrm>
-            <a:off x="9217938" y="3867864"/>
-            <a:ext cx="507444" cy="190500"/>
-          </a:xfrm>
-          <a:prstGeom prst="rect">
-            <a:avLst/>
-          </a:prstGeom>
-          <a:noFill/>
-          <a:ln/>
-        </p:spPr>
-        <p:txBody>
-          <a:bodyPr wrap="none" lIns="0" tIns="0" rIns="0" bIns="0" rtlCol="0" anchor="ctr"/>
-          <a:lstStyle/>
-          <a:p>
-            <a:pPr marL="0" indent="0" algn="l">
-              <a:buNone/>
-            </a:pPr>
-            <a:r>
-              <a:rPr lang="en-US" sz="1200" b="1" dirty="0">
-                <a:solidFill>
-                  <a:srgbClr val="FBBF24"/>
-                </a:solidFill>
-                <a:latin typeface="Arial" pitchFamily="34" charset="0"/>
-                <a:ea typeface="Arial" pitchFamily="34" charset="-122"/>
-                <a:cs typeface="Arial" pitchFamily="34" charset="-120"/>
-              </a:rPr>
-              <a:t>CI/CD</a:t>
-            </a:r>
-            <a:endParaRPr lang="en-US" sz="1200" dirty="0"/>
-          </a:p>
-        </p:txBody>
-      </p:sp>
-      <p:sp>
-        <p:nvSpPr>
-          <p:cNvPr id="20" name="static:18:text"/>
-          <p:cNvSpPr/>
-          <p:nvPr/>
-        </p:nvSpPr>
-        <p:spPr>
-          <a:xfrm>
-            <a:off x="9217938" y="4104084"/>
-            <a:ext cx="923806" cy="152400"/>
-          </a:xfrm>
-          <a:prstGeom prst="rect">
-            <a:avLst/>
-          </a:prstGeom>
-          <a:noFill/>
-          <a:ln/>
-        </p:spPr>
-        <p:txBody>
-          <a:bodyPr wrap="none" lIns="0" tIns="0" rIns="0" bIns="0" rtlCol="0" anchor="ctr"/>
-          <a:lstStyle/>
-          <a:p>
-            <a:pPr marL="0" indent="0" algn="l">
-              <a:buNone/>
-            </a:pPr>
-            <a:r>
-              <a:rPr lang="en-US" sz="960" dirty="0">
-                <a:solidFill>
-                  <a:srgbClr val="DEDEDE"/>
-                </a:solidFill>
-                <a:latin typeface="Arial" pitchFamily="34" charset="0"/>
-                <a:ea typeface="Arial" pitchFamily="34" charset="-122"/>
-                <a:cs typeface="Arial" pitchFamily="34" charset="-120"/>
-              </a:rPr>
-              <a:t>GitHub Actions</a:t>
-            </a:r>
-            <a:endParaRPr lang="en-US" sz="960" dirty="0"/>
           </a:p>
         </p:txBody>
       </p:sp>
@@ -12202,7 +11637,7 @@
               <a:buNone/>
             </a:pPr>
             <a:r>
-              <a:rPr lang="en-US" sz="1680" b="1" dirty="0">
+              <a:rPr lang="en-US" sz="2000" b="1" dirty="0">
                 <a:solidFill>
                   <a:srgbClr val="4DA6FF"/>
                 </a:solidFill>
@@ -12212,7 +11647,7 @@
               </a:rPr>
               <a:t>01</a:t>
             </a:r>
-            <a:endParaRPr lang="en-US" sz="1680" dirty="0"/>
+            <a:endParaRPr lang="en-US" sz="2000" dirty="0"/>
           </a:p>
         </p:txBody>
       </p:sp>
@@ -12241,7 +11676,7 @@
               <a:buNone/>
             </a:pPr>
             <a:r>
-              <a:rPr lang="en-US" sz="1680" b="1" dirty="0">
+              <a:rPr lang="en-US" sz="2000" b="1" dirty="0">
                 <a:solidFill>
                   <a:srgbClr val="DEDEDE"/>
                 </a:solidFill>
@@ -12251,7 +11686,7 @@
               </a:rPr>
               <a:t>Model Choice</a:t>
             </a:r>
-            <a:endParaRPr lang="en-US" sz="1680" dirty="0"/>
+            <a:endParaRPr lang="en-US" sz="2000" dirty="0"/>
           </a:p>
         </p:txBody>
       </p:sp>
@@ -12280,7 +11715,7 @@
               <a:buNone/>
             </a:pPr>
             <a:r>
-              <a:rPr lang="en-US" sz="1200" dirty="0">
+              <a:rPr lang="en-US" sz="1600" dirty="0">
                 <a:solidFill>
                   <a:srgbClr val="B0B0B0"/>
                 </a:solidFill>
@@ -12290,7 +11725,7 @@
               </a:rPr>
               <a:t>Model comparison + Model Router</a:t>
             </a:r>
-            <a:endParaRPr lang="en-US" sz="1200" dirty="0"/>
+            <a:endParaRPr lang="en-US" sz="1600" dirty="0"/>
           </a:p>
         </p:txBody>
       </p:sp>
@@ -12302,7 +11737,7 @@
         </p:nvSpPr>
         <p:spPr>
           <a:xfrm>
-            <a:off x="4256961" y="2251234"/>
+            <a:off x="4535741" y="2265472"/>
             <a:ext cx="374690" cy="266700"/>
           </a:xfrm>
           <a:prstGeom prst="rect">
@@ -12319,7 +11754,7 @@
               <a:buNone/>
             </a:pPr>
             <a:r>
-              <a:rPr lang="en-US" sz="1680" b="1" dirty="0">
+              <a:rPr lang="en-US" sz="2000" b="1" dirty="0">
                 <a:solidFill>
                   <a:srgbClr val="FD8EA1"/>
                 </a:solidFill>
@@ -12329,7 +11764,7 @@
               </a:rPr>
               <a:t>02</a:t>
             </a:r>
-            <a:endParaRPr lang="en-US" sz="1680" dirty="0"/>
+            <a:endParaRPr lang="en-US" sz="2000" dirty="0"/>
           </a:p>
         </p:txBody>
       </p:sp>
@@ -12341,7 +11776,7 @@
         </p:nvSpPr>
         <p:spPr>
           <a:xfrm>
-            <a:off x="4256961" y="2578894"/>
+            <a:off x="4535741" y="2593132"/>
             <a:ext cx="1142881" cy="266700"/>
           </a:xfrm>
           <a:prstGeom prst="rect">
@@ -12358,7 +11793,7 @@
               <a:buNone/>
             </a:pPr>
             <a:r>
-              <a:rPr lang="en-US" sz="1680" b="1" dirty="0">
+              <a:rPr lang="en-US" sz="2000" b="1" dirty="0">
                 <a:solidFill>
                   <a:srgbClr val="DEDEDE"/>
                 </a:solidFill>
@@ -12368,7 +11803,7 @@
               </a:rPr>
               <a:t>Grounding</a:t>
             </a:r>
-            <a:endParaRPr lang="en-US" sz="1680" dirty="0"/>
+            <a:endParaRPr lang="en-US" sz="2000" dirty="0"/>
           </a:p>
         </p:txBody>
       </p:sp>
@@ -12380,7 +11815,7 @@
         </p:nvSpPr>
         <p:spPr>
           <a:xfrm>
-            <a:off x="4256961" y="2912626"/>
+            <a:off x="4535741" y="2926864"/>
             <a:ext cx="2186583" cy="190500"/>
           </a:xfrm>
           <a:prstGeom prst="rect">
@@ -12397,7 +11832,7 @@
               <a:buNone/>
             </a:pPr>
             <a:r>
-              <a:rPr lang="en-US" sz="1200" dirty="0">
+              <a:rPr lang="en-US" sz="1600" dirty="0">
                 <a:solidFill>
                   <a:srgbClr val="B0B0B0"/>
                 </a:solidFill>
@@ -12407,20 +11842,20 @@
               </a:rPr>
               <a:t>Foundry IQ, Fabric IQ + Work IQ</a:t>
             </a:r>
-            <a:endParaRPr lang="en-US" sz="1200" dirty="0"/>
-          </a:p>
-        </p:txBody>
-      </p:sp>
-      <p:sp>
-        <p:nvSpPr>
-          <p:cNvPr id="10" name="static:8:text"/>
+            <a:endParaRPr lang="en-US" sz="1600" dirty="0"/>
+          </a:p>
+        </p:txBody>
+      </p:sp>
+      <p:sp>
+        <p:nvSpPr>
+          <p:cNvPr id="16" name="static:14:text"/>
           <p:cNvSpPr/>
           <p:nvPr/>
         </p:nvSpPr>
         <p:spPr>
           <a:xfrm>
-            <a:off x="7538680" y="2251234"/>
-            <a:ext cx="380881" cy="266700"/>
+            <a:off x="4535741" y="3637072"/>
+            <a:ext cx="378619" cy="266700"/>
           </a:xfrm>
           <a:prstGeom prst="rect">
             <a:avLst/>
@@ -12436,241 +11871,7 @@
               <a:buNone/>
             </a:pPr>
             <a:r>
-              <a:rPr lang="en-US" sz="1680" b="1" dirty="0">
-                <a:solidFill>
-                  <a:srgbClr val="FBBF24"/>
-                </a:solidFill>
-                <a:latin typeface="Arial" pitchFamily="34" charset="0"/>
-                <a:ea typeface="Arial" pitchFamily="34" charset="-122"/>
-                <a:cs typeface="Arial" pitchFamily="34" charset="-120"/>
-              </a:rPr>
-              <a:t>03</a:t>
-            </a:r>
-            <a:endParaRPr lang="en-US" sz="1680" dirty="0"/>
-          </a:p>
-        </p:txBody>
-      </p:sp>
-      <p:sp>
-        <p:nvSpPr>
-          <p:cNvPr id="11" name="static:9:text"/>
-          <p:cNvSpPr/>
-          <p:nvPr/>
-        </p:nvSpPr>
-        <p:spPr>
-          <a:xfrm>
-            <a:off x="7538680" y="2578894"/>
-            <a:ext cx="936546" cy="266700"/>
-          </a:xfrm>
-          <a:prstGeom prst="rect">
-            <a:avLst/>
-          </a:prstGeom>
-          <a:noFill/>
-          <a:ln/>
-        </p:spPr>
-        <p:txBody>
-          <a:bodyPr wrap="none" lIns="0" tIns="0" rIns="0" bIns="0" rtlCol="0" anchor="ctr"/>
-          <a:lstStyle/>
-          <a:p>
-            <a:pPr marL="0" indent="0" algn="l">
-              <a:buNone/>
-            </a:pPr>
-            <a:r>
-              <a:rPr lang="en-US" sz="1680" b="1" dirty="0">
-                <a:solidFill>
-                  <a:srgbClr val="DEDEDE"/>
-                </a:solidFill>
-                <a:latin typeface="Arial" pitchFamily="34" charset="0"/>
-                <a:ea typeface="Arial" pitchFamily="34" charset="-122"/>
-                <a:cs typeface="Arial" pitchFamily="34" charset="-120"/>
-              </a:rPr>
-              <a:t>Observe</a:t>
-            </a:r>
-            <a:endParaRPr lang="en-US" sz="1680" dirty="0"/>
-          </a:p>
-        </p:txBody>
-      </p:sp>
-      <p:sp>
-        <p:nvSpPr>
-          <p:cNvPr id="12" name="static:10:text"/>
-          <p:cNvSpPr/>
-          <p:nvPr/>
-        </p:nvSpPr>
-        <p:spPr>
-          <a:xfrm>
-            <a:off x="7538680" y="2912626"/>
-            <a:ext cx="1894999" cy="190500"/>
-          </a:xfrm>
-          <a:prstGeom prst="rect">
-            <a:avLst/>
-          </a:prstGeom>
-          <a:noFill/>
-          <a:ln/>
-        </p:spPr>
-        <p:txBody>
-          <a:bodyPr wrap="none" lIns="0" tIns="0" rIns="0" bIns="0" rtlCol="0" anchor="ctr"/>
-          <a:lstStyle/>
-          <a:p>
-            <a:pPr marL="0" indent="0" algn="l">
-              <a:buNone/>
-            </a:pPr>
-            <a:r>
-              <a:rPr lang="en-US" sz="1200" dirty="0">
-                <a:solidFill>
-                  <a:srgbClr val="B0B0B0"/>
-                </a:solidFill>
-                <a:latin typeface="Arial" pitchFamily="34" charset="0"/>
-                <a:ea typeface="Arial" pitchFamily="34" charset="-122"/>
-                <a:cs typeface="Arial" pitchFamily="34" charset="-120"/>
-              </a:rPr>
-              <a:t>Foundry tracing + tool calls</a:t>
-            </a:r>
-            <a:endParaRPr lang="en-US" sz="1200" dirty="0"/>
-          </a:p>
-        </p:txBody>
-      </p:sp>
-      <p:sp>
-        <p:nvSpPr>
-          <p:cNvPr id="13" name="static:11:text"/>
-          <p:cNvSpPr/>
-          <p:nvPr/>
-        </p:nvSpPr>
-        <p:spPr>
-          <a:xfrm>
-            <a:off x="975360" y="3622834"/>
-            <a:ext cx="385286" cy="266700"/>
-          </a:xfrm>
-          <a:prstGeom prst="rect">
-            <a:avLst/>
-          </a:prstGeom>
-          <a:noFill/>
-          <a:ln/>
-        </p:spPr>
-        <p:txBody>
-          <a:bodyPr wrap="none" lIns="0" tIns="0" rIns="0" bIns="0" rtlCol="0" anchor="ctr"/>
-          <a:lstStyle/>
-          <a:p>
-            <a:pPr marL="0" indent="0" algn="l">
-              <a:buNone/>
-            </a:pPr>
-            <a:r>
-              <a:rPr lang="en-US" sz="1680" b="1" dirty="0">
-                <a:solidFill>
-                  <a:srgbClr val="4ADE80"/>
-                </a:solidFill>
-                <a:latin typeface="Arial" pitchFamily="34" charset="0"/>
-                <a:ea typeface="Arial" pitchFamily="34" charset="-122"/>
-                <a:cs typeface="Arial" pitchFamily="34" charset="-120"/>
-              </a:rPr>
-              <a:t>04</a:t>
-            </a:r>
-            <a:endParaRPr lang="en-US" sz="1680" dirty="0"/>
-          </a:p>
-        </p:txBody>
-      </p:sp>
-      <p:sp>
-        <p:nvSpPr>
-          <p:cNvPr id="14" name="static:12:text"/>
-          <p:cNvSpPr/>
-          <p:nvPr/>
-        </p:nvSpPr>
-        <p:spPr>
-          <a:xfrm>
-            <a:off x="975360" y="3950494"/>
-            <a:ext cx="948214" cy="266700"/>
-          </a:xfrm>
-          <a:prstGeom prst="rect">
-            <a:avLst/>
-          </a:prstGeom>
-          <a:noFill/>
-          <a:ln/>
-        </p:spPr>
-        <p:txBody>
-          <a:bodyPr wrap="none" lIns="0" tIns="0" rIns="0" bIns="0" rtlCol="0" anchor="ctr"/>
-          <a:lstStyle/>
-          <a:p>
-            <a:pPr marL="0" indent="0" algn="l">
-              <a:buNone/>
-            </a:pPr>
-            <a:r>
-              <a:rPr lang="en-US" sz="1680" b="1" dirty="0">
-                <a:solidFill>
-                  <a:srgbClr val="DEDEDE"/>
-                </a:solidFill>
-                <a:latin typeface="Arial" pitchFamily="34" charset="0"/>
-                <a:ea typeface="Arial" pitchFamily="34" charset="-122"/>
-                <a:cs typeface="Arial" pitchFamily="34" charset="-120"/>
-              </a:rPr>
-              <a:t>Evaluate</a:t>
-            </a:r>
-            <a:endParaRPr lang="en-US" sz="1680" dirty="0"/>
-          </a:p>
-        </p:txBody>
-      </p:sp>
-      <p:sp>
-        <p:nvSpPr>
-          <p:cNvPr id="15" name="static:13:text"/>
-          <p:cNvSpPr/>
-          <p:nvPr/>
-        </p:nvSpPr>
-        <p:spPr>
-          <a:xfrm>
-            <a:off x="975360" y="4284226"/>
-            <a:ext cx="2065734" cy="190500"/>
-          </a:xfrm>
-          <a:prstGeom prst="rect">
-            <a:avLst/>
-          </a:prstGeom>
-          <a:noFill/>
-          <a:ln/>
-        </p:spPr>
-        <p:txBody>
-          <a:bodyPr wrap="none" lIns="0" tIns="0" rIns="0" bIns="0" rtlCol="0" anchor="ctr"/>
-          <a:lstStyle/>
-          <a:p>
-            <a:pPr marL="0" indent="0" algn="l">
-              <a:buNone/>
-            </a:pPr>
-            <a:r>
-              <a:rPr lang="en-US" sz="1200" dirty="0">
-                <a:solidFill>
-                  <a:srgbClr val="B0B0B0"/>
-                </a:solidFill>
-                <a:latin typeface="Arial" pitchFamily="34" charset="0"/>
-                <a:ea typeface="Arial" pitchFamily="34" charset="-122"/>
-                <a:cs typeface="Arial" pitchFamily="34" charset="-120"/>
-              </a:rPr>
-              <a:t>Quality, latency, tokens + cost</a:t>
-            </a:r>
-            <a:endParaRPr lang="en-US" sz="1200" dirty="0"/>
-          </a:p>
-        </p:txBody>
-      </p:sp>
-      <p:sp>
-        <p:nvSpPr>
-          <p:cNvPr id="16" name="static:14:text"/>
-          <p:cNvSpPr/>
-          <p:nvPr/>
-        </p:nvSpPr>
-        <p:spPr>
-          <a:xfrm>
-            <a:off x="4256961" y="3622834"/>
-            <a:ext cx="378619" cy="266700"/>
-          </a:xfrm>
-          <a:prstGeom prst="rect">
-            <a:avLst/>
-          </a:prstGeom>
-          <a:noFill/>
-          <a:ln/>
-        </p:spPr>
-        <p:txBody>
-          <a:bodyPr wrap="none" lIns="0" tIns="0" rIns="0" bIns="0" rtlCol="0" anchor="ctr"/>
-          <a:lstStyle/>
-          <a:p>
-            <a:pPr marL="0" indent="0" algn="l">
-              <a:buNone/>
-            </a:pPr>
-            <a:r>
-              <a:rPr lang="en-US" sz="1680" b="1" dirty="0">
+              <a:rPr lang="en-US" sz="2000" b="1" dirty="0">
                 <a:solidFill>
                   <a:srgbClr val="F87171"/>
                 </a:solidFill>
@@ -12680,7 +11881,7 @@
               </a:rPr>
               <a:t>05</a:t>
             </a:r>
-            <a:endParaRPr lang="en-US" sz="1680" dirty="0"/>
+            <a:endParaRPr lang="en-US" sz="2000" dirty="0"/>
           </a:p>
         </p:txBody>
       </p:sp>
@@ -12692,7 +11893,7 @@
         </p:nvSpPr>
         <p:spPr>
           <a:xfrm>
-            <a:off x="4256961" y="3950494"/>
+            <a:off x="4535741" y="3964732"/>
             <a:ext cx="992981" cy="266700"/>
           </a:xfrm>
           <a:prstGeom prst="rect">
@@ -12709,7 +11910,7 @@
               <a:buNone/>
             </a:pPr>
             <a:r>
-              <a:rPr lang="en-US" sz="1680" b="1" dirty="0">
+              <a:rPr lang="en-US" sz="2000" b="1" dirty="0">
                 <a:solidFill>
                   <a:srgbClr val="DEDEDE"/>
                 </a:solidFill>
@@ -12719,7 +11920,7 @@
               </a:rPr>
               <a:t>Optimise</a:t>
             </a:r>
-            <a:endParaRPr lang="en-US" sz="1680" dirty="0"/>
+            <a:endParaRPr lang="en-US" sz="2000" dirty="0"/>
           </a:p>
         </p:txBody>
       </p:sp>
@@ -12731,7 +11932,7 @@
         </p:nvSpPr>
         <p:spPr>
           <a:xfrm>
-            <a:off x="4256961" y="4284226"/>
+            <a:off x="4535741" y="4298464"/>
             <a:ext cx="1173599" cy="190500"/>
           </a:xfrm>
           <a:prstGeom prst="rect">
@@ -12748,7 +11949,7 @@
               <a:buNone/>
             </a:pPr>
             <a:r>
-              <a:rPr lang="en-US" sz="1200" dirty="0">
+              <a:rPr lang="en-US" sz="1600" dirty="0">
                 <a:solidFill>
                   <a:srgbClr val="B0B0B0"/>
                 </a:solidFill>
@@ -12758,7 +11959,7 @@
               </a:rPr>
               <a:t>Agent Optimizer</a:t>
             </a:r>
-            <a:endParaRPr lang="en-US" sz="1200" dirty="0"/>
+            <a:endParaRPr lang="en-US" sz="1600" dirty="0"/>
           </a:p>
         </p:txBody>
       </p:sp>
@@ -12770,7 +11971,7 @@
         </p:nvSpPr>
         <p:spPr>
           <a:xfrm>
-            <a:off x="7538680" y="3622834"/>
+            <a:off x="7817460" y="3637072"/>
             <a:ext cx="385405" cy="266700"/>
           </a:xfrm>
           <a:prstGeom prst="rect">
@@ -12787,7 +11988,7 @@
               <a:buNone/>
             </a:pPr>
             <a:r>
-              <a:rPr lang="en-US" sz="1680" b="1" dirty="0">
+              <a:rPr lang="en-US" sz="2000" b="1" dirty="0">
                 <a:solidFill>
                   <a:srgbClr val="4DA6FF"/>
                 </a:solidFill>
@@ -12797,7 +11998,7 @@
               </a:rPr>
               <a:t>06</a:t>
             </a:r>
-            <a:endParaRPr lang="en-US" sz="1680" dirty="0"/>
+            <a:endParaRPr lang="en-US" sz="2000" dirty="0"/>
           </a:p>
         </p:txBody>
       </p:sp>
@@ -12809,7 +12010,7 @@
         </p:nvSpPr>
         <p:spPr>
           <a:xfrm>
-            <a:off x="7538680" y="3950494"/>
+            <a:off x="7817460" y="3964732"/>
             <a:ext cx="1072039" cy="266700"/>
           </a:xfrm>
           <a:prstGeom prst="rect">
@@ -12826,7 +12027,7 @@
               <a:buNone/>
             </a:pPr>
             <a:r>
-              <a:rPr lang="en-US" sz="1680" b="1" dirty="0">
+              <a:rPr lang="en-US" sz="2000" b="1" dirty="0">
                 <a:solidFill>
                   <a:srgbClr val="DEDEDE"/>
                 </a:solidFill>
@@ -12836,7 +12037,7 @@
               </a:rPr>
               <a:t>Automate</a:t>
             </a:r>
-            <a:endParaRPr lang="en-US" sz="1680" dirty="0"/>
+            <a:endParaRPr lang="en-US" sz="2000" dirty="0"/>
           </a:p>
         </p:txBody>
       </p:sp>
@@ -12848,8 +12049,8 @@
         </p:nvSpPr>
         <p:spPr>
           <a:xfrm>
-            <a:off x="7538680" y="4284226"/>
-            <a:ext cx="1571387" cy="190500"/>
+            <a:off x="7817460" y="4231432"/>
+            <a:ext cx="3856380" cy="243294"/>
           </a:xfrm>
           <a:prstGeom prst="rect">
             <a:avLst/>
@@ -12861,11 +12062,8 @@
           <a:bodyPr wrap="none" lIns="0" tIns="0" rIns="0" bIns="0" rtlCol="0" anchor="ctr"/>
           <a:lstStyle/>
           <a:p>
-            <a:pPr marL="0" indent="0" algn="l">
-              <a:buNone/>
-            </a:pPr>
             <a:r>
-              <a:rPr lang="en-US" sz="1200" dirty="0">
+              <a:rPr lang="en-US" sz="1600" dirty="0">
                 <a:solidFill>
                   <a:srgbClr val="B0B0B0"/>
                 </a:solidFill>
@@ -12873,9 +12071,9 @@
                 <a:ea typeface="Arial" pitchFamily="34" charset="-122"/>
                 <a:cs typeface="Arial" pitchFamily="34" charset="-120"/>
               </a:rPr>
-              <a:t>Continuous evaluation</a:t>
+              <a:t>Continuous evaluation + GitHub Actions</a:t>
             </a:r>
-            <a:endParaRPr lang="en-US" sz="1200" dirty="0"/>
+            <a:endParaRPr lang="en-US" sz="1600" dirty="0"/>
           </a:p>
         </p:txBody>
       </p:sp>
@@ -12887,7 +12085,7 @@
         </p:nvSpPr>
         <p:spPr>
           <a:xfrm>
-            <a:off x="7538680" y="4482346"/>
+            <a:off x="7817460" y="4496584"/>
             <a:ext cx="1227296" cy="190500"/>
           </a:xfrm>
           <a:prstGeom prst="rect">
@@ -12903,18 +12101,7 @@
             <a:pPr marL="0" indent="0" algn="l">
               <a:buNone/>
             </a:pPr>
-            <a:r>
-              <a:rPr lang="en-US" sz="1200" dirty="0">
-                <a:solidFill>
-                  <a:srgbClr val="B0B0B0"/>
-                </a:solidFill>
-                <a:latin typeface="Arial" pitchFamily="34" charset="0"/>
-                <a:ea typeface="Arial" pitchFamily="34" charset="-122"/>
-                <a:cs typeface="Arial" pitchFamily="34" charset="-120"/>
-              </a:rPr>
-              <a:t>+ GitHub Actions</a:t>
-            </a:r>
-            <a:endParaRPr lang="en-US" sz="1200" dirty="0"/>
+            <a:endParaRPr lang="en-US" sz="1600" dirty="0"/>
           </a:p>
         </p:txBody>
       </p:sp>
@@ -12993,6 +12180,276 @@
               <a:t>AI GENIUS / S6 E2 / 02</a:t>
             </a:r>
             <a:endParaRPr lang="en-US" sz="720" dirty="0"/>
+          </a:p>
+        </p:txBody>
+      </p:sp>
+      <p:sp>
+        <p:nvSpPr>
+          <p:cNvPr id="25" name="static:11:text">
+            <a:extLst>
+              <a:ext uri="{FF2B5EF4-FFF2-40B4-BE49-F238E27FC236}">
+                <a16:creationId xmlns:a16="http://schemas.microsoft.com/office/drawing/2014/main" id="{46F7BA72-CF14-DB79-C5D6-9262140E2D71}"/>
+              </a:ext>
+            </a:extLst>
+          </p:cNvPr>
+          <p:cNvSpPr/>
+          <p:nvPr/>
+        </p:nvSpPr>
+        <p:spPr>
+          <a:xfrm>
+            <a:off x="7817460" y="2251234"/>
+            <a:ext cx="385286" cy="266700"/>
+          </a:xfrm>
+          <a:prstGeom prst="rect">
+            <a:avLst/>
+          </a:prstGeom>
+          <a:noFill/>
+          <a:ln/>
+        </p:spPr>
+        <p:txBody>
+          <a:bodyPr wrap="none" lIns="0" tIns="0" rIns="0" bIns="0" rtlCol="0" anchor="ctr"/>
+          <a:lstStyle/>
+          <a:p>
+            <a:pPr marL="0" indent="0" algn="l">
+              <a:buNone/>
+            </a:pPr>
+            <a:r>
+              <a:rPr lang="en-US" sz="2000" b="1" dirty="0">
+                <a:solidFill>
+                  <a:srgbClr val="4ADE80"/>
+                </a:solidFill>
+                <a:latin typeface="Arial" pitchFamily="34" charset="0"/>
+                <a:ea typeface="Arial" pitchFamily="34" charset="-122"/>
+                <a:cs typeface="Arial" pitchFamily="34" charset="-120"/>
+              </a:rPr>
+              <a:t>03</a:t>
+            </a:r>
+            <a:endParaRPr lang="en-US" sz="2000" dirty="0"/>
+          </a:p>
+        </p:txBody>
+      </p:sp>
+      <p:sp>
+        <p:nvSpPr>
+          <p:cNvPr id="26" name="static:12:text">
+            <a:extLst>
+              <a:ext uri="{FF2B5EF4-FFF2-40B4-BE49-F238E27FC236}">
+                <a16:creationId xmlns:a16="http://schemas.microsoft.com/office/drawing/2014/main" id="{DC9D1AEF-5283-3F46-85E0-99FD3B08DD09}"/>
+              </a:ext>
+            </a:extLst>
+          </p:cNvPr>
+          <p:cNvSpPr/>
+          <p:nvPr/>
+        </p:nvSpPr>
+        <p:spPr>
+          <a:xfrm>
+            <a:off x="7817460" y="2578894"/>
+            <a:ext cx="948214" cy="266700"/>
+          </a:xfrm>
+          <a:prstGeom prst="rect">
+            <a:avLst/>
+          </a:prstGeom>
+          <a:noFill/>
+          <a:ln/>
+        </p:spPr>
+        <p:txBody>
+          <a:bodyPr wrap="none" lIns="0" tIns="0" rIns="0" bIns="0" rtlCol="0" anchor="ctr"/>
+          <a:lstStyle/>
+          <a:p>
+            <a:pPr marL="0" indent="0" algn="l">
+              <a:buNone/>
+            </a:pPr>
+            <a:r>
+              <a:rPr lang="en-US" sz="2000" b="1" dirty="0">
+                <a:solidFill>
+                  <a:srgbClr val="DEDEDE"/>
+                </a:solidFill>
+                <a:latin typeface="Arial" pitchFamily="34" charset="0"/>
+                <a:ea typeface="Arial" pitchFamily="34" charset="-122"/>
+                <a:cs typeface="Arial" pitchFamily="34" charset="-120"/>
+              </a:rPr>
+              <a:t>Evaluate</a:t>
+            </a:r>
+            <a:endParaRPr lang="en-US" sz="2000" dirty="0"/>
+          </a:p>
+        </p:txBody>
+      </p:sp>
+      <p:sp>
+        <p:nvSpPr>
+          <p:cNvPr id="27" name="static:13:text">
+            <a:extLst>
+              <a:ext uri="{FF2B5EF4-FFF2-40B4-BE49-F238E27FC236}">
+                <a16:creationId xmlns:a16="http://schemas.microsoft.com/office/drawing/2014/main" id="{E094F1BF-7F3B-FF59-1E91-CAA7077A788D}"/>
+              </a:ext>
+            </a:extLst>
+          </p:cNvPr>
+          <p:cNvSpPr/>
+          <p:nvPr/>
+        </p:nvSpPr>
+        <p:spPr>
+          <a:xfrm>
+            <a:off x="7817459" y="2912626"/>
+            <a:ext cx="2965769" cy="190500"/>
+          </a:xfrm>
+          <a:prstGeom prst="rect">
+            <a:avLst/>
+          </a:prstGeom>
+          <a:noFill/>
+          <a:ln/>
+        </p:spPr>
+        <p:txBody>
+          <a:bodyPr wrap="none" lIns="0" tIns="0" rIns="0" bIns="0" rtlCol="0" anchor="ctr"/>
+          <a:lstStyle/>
+          <a:p>
+            <a:pPr marL="0" indent="0" algn="l">
+              <a:buNone/>
+            </a:pPr>
+            <a:r>
+              <a:rPr lang="en-US" sz="1600" dirty="0">
+                <a:solidFill>
+                  <a:srgbClr val="B0B0B0"/>
+                </a:solidFill>
+                <a:latin typeface="Arial" pitchFamily="34" charset="0"/>
+                <a:ea typeface="Arial" pitchFamily="34" charset="-122"/>
+                <a:cs typeface="Arial" pitchFamily="34" charset="-120"/>
+              </a:rPr>
+              <a:t>Quality, safety, stays on-task</a:t>
+            </a:r>
+            <a:endParaRPr lang="en-US" sz="1600" dirty="0"/>
+          </a:p>
+        </p:txBody>
+      </p:sp>
+      <p:sp>
+        <p:nvSpPr>
+          <p:cNvPr id="28" name="static:8:text">
+            <a:extLst>
+              <a:ext uri="{FF2B5EF4-FFF2-40B4-BE49-F238E27FC236}">
+                <a16:creationId xmlns:a16="http://schemas.microsoft.com/office/drawing/2014/main" id="{E56A732E-8F30-CD8D-7275-EA11D4A84FDF}"/>
+              </a:ext>
+            </a:extLst>
+          </p:cNvPr>
+          <p:cNvSpPr/>
+          <p:nvPr/>
+        </p:nvSpPr>
+        <p:spPr>
+          <a:xfrm>
+            <a:off x="975360" y="3658806"/>
+            <a:ext cx="380881" cy="266700"/>
+          </a:xfrm>
+          <a:prstGeom prst="rect">
+            <a:avLst/>
+          </a:prstGeom>
+          <a:noFill/>
+          <a:ln/>
+        </p:spPr>
+        <p:txBody>
+          <a:bodyPr wrap="none" lIns="0" tIns="0" rIns="0" bIns="0" rtlCol="0" anchor="ctr"/>
+          <a:lstStyle/>
+          <a:p>
+            <a:pPr marL="0" indent="0" algn="l">
+              <a:buNone/>
+            </a:pPr>
+            <a:r>
+              <a:rPr lang="en-US" sz="2000" b="1" dirty="0">
+                <a:solidFill>
+                  <a:srgbClr val="FBBF24"/>
+                </a:solidFill>
+                <a:latin typeface="Arial" pitchFamily="34" charset="0"/>
+                <a:ea typeface="Arial" pitchFamily="34" charset="-122"/>
+                <a:cs typeface="Arial" pitchFamily="34" charset="-120"/>
+              </a:rPr>
+              <a:t>03</a:t>
+            </a:r>
+            <a:endParaRPr lang="en-US" sz="2000" dirty="0"/>
+          </a:p>
+        </p:txBody>
+      </p:sp>
+      <p:sp>
+        <p:nvSpPr>
+          <p:cNvPr id="29" name="static:9:text">
+            <a:extLst>
+              <a:ext uri="{FF2B5EF4-FFF2-40B4-BE49-F238E27FC236}">
+                <a16:creationId xmlns:a16="http://schemas.microsoft.com/office/drawing/2014/main" id="{20133A28-79B6-B053-E2A8-D6393DE731EE}"/>
+              </a:ext>
+            </a:extLst>
+          </p:cNvPr>
+          <p:cNvSpPr/>
+          <p:nvPr/>
+        </p:nvSpPr>
+        <p:spPr>
+          <a:xfrm>
+            <a:off x="986511" y="3986466"/>
+            <a:ext cx="1752600" cy="244966"/>
+          </a:xfrm>
+          <a:prstGeom prst="rect">
+            <a:avLst/>
+          </a:prstGeom>
+          <a:noFill/>
+          <a:ln/>
+        </p:spPr>
+        <p:txBody>
+          <a:bodyPr wrap="none" lIns="0" tIns="0" rIns="0" bIns="0" rtlCol="0" anchor="ctr"/>
+          <a:lstStyle/>
+          <a:p>
+            <a:pPr marL="0" indent="0" algn="l">
+              <a:buNone/>
+            </a:pPr>
+            <a:r>
+              <a:rPr lang="en-US" sz="2000" b="1" dirty="0">
+                <a:solidFill>
+                  <a:srgbClr val="DEDEDE"/>
+                </a:solidFill>
+                <a:latin typeface="Arial" pitchFamily="34" charset="0"/>
+                <a:ea typeface="Arial" pitchFamily="34" charset="-122"/>
+                <a:cs typeface="Arial" pitchFamily="34" charset="-120"/>
+              </a:rPr>
+              <a:t>Observability</a:t>
+            </a:r>
+            <a:endParaRPr lang="en-US" sz="2000" dirty="0"/>
+          </a:p>
+        </p:txBody>
+      </p:sp>
+      <p:sp>
+        <p:nvSpPr>
+          <p:cNvPr id="30" name="static:10:text">
+            <a:extLst>
+              <a:ext uri="{FF2B5EF4-FFF2-40B4-BE49-F238E27FC236}">
+                <a16:creationId xmlns:a16="http://schemas.microsoft.com/office/drawing/2014/main" id="{BEA8599D-63C7-A5D6-7BCF-AEE8E0DE2EC6}"/>
+              </a:ext>
+            </a:extLst>
+          </p:cNvPr>
+          <p:cNvSpPr/>
+          <p:nvPr/>
+        </p:nvSpPr>
+        <p:spPr>
+          <a:xfrm>
+            <a:off x="975360" y="4320198"/>
+            <a:ext cx="1894999" cy="190500"/>
+          </a:xfrm>
+          <a:prstGeom prst="rect">
+            <a:avLst/>
+          </a:prstGeom>
+          <a:noFill/>
+          <a:ln/>
+        </p:spPr>
+        <p:txBody>
+          <a:bodyPr wrap="none" lIns="0" tIns="0" rIns="0" bIns="0" rtlCol="0" anchor="ctr"/>
+          <a:lstStyle/>
+          <a:p>
+            <a:pPr marL="0" indent="0" algn="l">
+              <a:buNone/>
+            </a:pPr>
+            <a:r>
+              <a:rPr lang="en-US" sz="1600" dirty="0">
+                <a:solidFill>
+                  <a:srgbClr val="B0B0B0"/>
+                </a:solidFill>
+                <a:latin typeface="Arial" pitchFamily="34" charset="0"/>
+                <a:ea typeface="Arial" pitchFamily="34" charset="-122"/>
+                <a:cs typeface="Arial" pitchFamily="34" charset="-120"/>
+              </a:rPr>
+              <a:t>Foundry tracing</a:t>
+            </a:r>
+            <a:endParaRPr lang="en-US" sz="1600" dirty="0"/>
           </a:p>
         </p:txBody>
       </p:sp>
@@ -14874,6 +14331,51 @@
               <a:t>AI GENIUS / S6 E2 / 04</a:t>
             </a:r>
             <a:endParaRPr lang="en-US" sz="720" dirty="0"/>
+          </a:p>
+        </p:txBody>
+      </p:sp>
+      <p:sp>
+        <p:nvSpPr>
+          <p:cNvPr id="39" name="reveal-1:5:text">
+            <a:extLst>
+              <a:ext uri="{FF2B5EF4-FFF2-40B4-BE49-F238E27FC236}">
+                <a16:creationId xmlns:a16="http://schemas.microsoft.com/office/drawing/2014/main" id="{331D5248-8C74-A1DD-589D-B0FEC9852322}"/>
+              </a:ext>
+            </a:extLst>
+          </p:cNvPr>
+          <p:cNvSpPr/>
+          <p:nvPr/>
+        </p:nvSpPr>
+        <p:spPr>
+          <a:xfrm>
+            <a:off x="3461862" y="5686247"/>
+            <a:ext cx="4633703" cy="311824"/>
+          </a:xfrm>
+          <a:prstGeom prst="rect">
+            <a:avLst/>
+          </a:prstGeom>
+          <a:noFill/>
+          <a:ln/>
+        </p:spPr>
+        <p:txBody>
+          <a:bodyPr wrap="none" lIns="0" tIns="0" rIns="0" bIns="0" rtlCol="0" anchor="ctr"/>
+          <a:lstStyle/>
+          <a:p>
+            <a:pPr marL="0" indent="0" algn="l">
+              <a:buNone/>
+            </a:pPr>
+            <a:r>
+              <a:rPr lang="en-US" sz="1560" b="1" dirty="0">
+                <a:solidFill>
+                  <a:srgbClr val="DEDEDE"/>
+                </a:solidFill>
+                <a:latin typeface="Arial" pitchFamily="34" charset="0"/>
+                <a:ea typeface="Arial" pitchFamily="34" charset="-122"/>
+                <a:cs typeface="Arial" pitchFamily="34" charset="-120"/>
+              </a:rPr>
+              <a:t>Or a model which can decide on the fly?</a:t>
+            </a:r>
+            <a:endParaRPr lang="en-US" sz="1560" dirty="0"/>
           </a:p>
         </p:txBody>
       </p:sp>
@@ -16262,7 +15764,13 @@
       </p:grpSp>
       <p:grpSp>
         <p:nvGrpSpPr>
-          <p:cNvPr id="40" name="Reveal 3"/>
+          <p:cNvPr id="41" name="Group 40">
+            <a:extLst>
+              <a:ext uri="{FF2B5EF4-FFF2-40B4-BE49-F238E27FC236}">
+                <a16:creationId xmlns:a16="http://schemas.microsoft.com/office/drawing/2014/main" id="{AE4E581A-2C22-B249-A8A6-1CDB33248A80}"/>
+              </a:ext>
+            </a:extLst>
+          </p:cNvPr>
           <p:cNvGrpSpPr/>
           <p:nvPr/>
         </p:nvGrpSpPr>
@@ -16501,7 +16009,7 @@
           </p:nvSpPr>
           <p:spPr>
             <a:xfrm>
-              <a:off x="7927300" y="3456623"/>
+              <a:off x="7927300" y="3652004"/>
               <a:ext cx="2809161" cy="636984"/>
             </a:xfrm>
             <a:prstGeom prst="roundRect">
@@ -16539,7 +16047,7 @@
           </p:nvSpPr>
           <p:spPr>
             <a:xfrm>
-              <a:off x="8033980" y="3540443"/>
+              <a:off x="8033980" y="3735824"/>
               <a:ext cx="2128123" cy="152400"/>
             </a:xfrm>
             <a:prstGeom prst="rect">
@@ -16578,7 +16086,7 @@
           </p:nvSpPr>
           <p:spPr>
             <a:xfrm>
-              <a:off x="8033980" y="3689033"/>
+              <a:off x="8033980" y="3884414"/>
               <a:ext cx="675918" cy="152400"/>
             </a:xfrm>
             <a:prstGeom prst="rect">
@@ -16617,7 +16125,7 @@
           </p:nvSpPr>
           <p:spPr>
             <a:xfrm>
-              <a:off x="8033980" y="3875723"/>
+              <a:off x="8033980" y="4071104"/>
               <a:ext cx="2207181" cy="129540"/>
             </a:xfrm>
             <a:prstGeom prst="rect">
@@ -16812,51 +16320,6 @@
                                         </p:cTn>
                                         <p:tgtEl>
                                           <p:spTgt spid="39"/>
-                                        </p:tgtEl>
-                                        <p:attrNameLst>
-                                          <p:attrName>style.visibility</p:attrName>
-                                        </p:attrNameLst>
-                                      </p:cBhvr>
-                                      <p:to>
-                                        <p:strVal val="visible"/>
-                                      </p:to>
-                                    </p:set>
-                                  </p:childTnLst>
-                                </p:cTn>
-                              </p:par>
-                            </p:childTnLst>
-                          </p:cTn>
-                        </p:par>
-                      </p:childTnLst>
-                    </p:cTn>
-                  </p:par>
-                  <p:par>
-                    <p:cTn id="11" fill="hold">
-                      <p:stCondLst>
-                        <p:cond delay="indefinite"/>
-                      </p:stCondLst>
-                      <p:childTnLst>
-                        <p:par>
-                          <p:cTn id="12" fill="hold">
-                            <p:stCondLst>
-                              <p:cond delay="0"/>
-                            </p:stCondLst>
-                            <p:childTnLst>
-                              <p:par>
-                                <p:cTn id="13" presetID="1" presetClass="entr" presetSubtype="0" fill="hold" nodeType="clickEffect">
-                                  <p:stCondLst>
-                                    <p:cond delay="0"/>
-                                  </p:stCondLst>
-                                  <p:childTnLst>
-                                    <p:set>
-                                      <p:cBhvr>
-                                        <p:cTn id="14" dur="1" fill="hold">
-                                          <p:stCondLst>
-                                            <p:cond delay="0"/>
-                                          </p:stCondLst>
-                                        </p:cTn>
-                                        <p:tgtEl>
-                                          <p:spTgt spid="40"/>
                                         </p:tgtEl>
                                         <p:attrNameLst>
                                           <p:attrName>style.visibility</p:attrName>

</xml_diff>

<commit_message>
Label the Foundry eval GitHub Action as an alternative; remove change log
- References slide: mark the official action as an alternative
- Demo 6 notes: explain why the gates use our own run ID check
- Remove CHANGES-2026-10-11.md (historical; confusing for new users)

Co-authored-by: Copilot <223556219+Copilot@users.noreply.github.com>
Copilot-Session: 84615fb9-e33a-48ce-994c-25c19eb2bf5f
</commit_message>
<xml_diff>
--- a/presentation/presentation.pptx
+++ b/presentation/presentation.pptx
@@ -1230,13 +1230,13 @@
 DEFINITION
 A pull request check runs on every proposed change; it blocks merging only if the branch's ruleset requires it.
 TALK TRACK
-Two prepared pull requests. First, the reviewed improvement: the development set passed on the PR; after merge, main evaluated -dev on the holdout, a reviewer inspected it, every drift case passed, then a separate release approval deployed the same commit. Second, the bad prompt: no tools, the same answer every time. The cheap offline checks pass, but the development set fails against the baseline, and because branch protection requires that check, it can't be merged normally. Optionally run the fact check live on the old copied-facts candidate: one second, no model. The gate only asks that a change not fall below the baseline by more than the normal wobble. Admins can still bypass, and every bypass is recorded.
+Two prepared pull requests. First, the reviewed improvement: the development set passed on the PR; after merge, main evaluated -dev on the holdout, a reviewer inspected it, every drift case passed, then a separate release approval deployed the same commit. Second, the bad prompt: no tools, the same answer every time. The cheap offline checks pass, but the development set fails against the baseline, and because branch protection requires that check, it can't be merged normally. Optionally run the fact check live on the old copied-facts candidate: one second, no model. The gate only asks that a change not fall below the baseline by more than the normal wobble. Admins can still bypass, and every bypass is recorded. If asked about the official Foundry evaluation GitHub Action: it uses the same evaluation API, but only writes a report. It exposes no run ID or pass/fail result, so it can't gate a merge. We kept our run ID and added the gate.
 DEMO CHECKPOINT
 Prepared: both pull requests and the main promotion run, opened after the optimizer finished. Live (optional): the fact-check command from the playbook. If CI isn't working on the day, use slides 14 and 15 with the live command.
 TRANSITION
 And after release, production keeps feeding the tests.
 SOURCES
-GitHub Actions release-check demonstration.</a:t>
+GitHub Actions release-check demonstration; microsoft/ai-agent-evals v3-beta action.py (checked 19 October 2026).</a:t>
             </a:r>
             <a:endParaRPr lang="en-US" dirty="0"/>
           </a:p>
@@ -18702,7 +18702,7 @@
         <p:spPr>
           <a:xfrm>
             <a:off x="8313420" y="2684740"/>
-            <a:ext cx="1743313" cy="182880"/>
+            <a:ext cx="1803559" cy="182880"/>
           </a:xfrm>
           <a:prstGeom prst="rect">
             <a:avLst/>
@@ -18733,7 +18733,7 @@
                   </a:extLst>
                 </a:hlinkClick>
               </a:rPr>
-              <a:t>Run evaluations in GitHub</a:t>
+              <a:t>Foundry evaluation GitHub</a:t>
             </a:r>
             <a:endParaRPr lang="en-US" sz="1140" dirty="0"/>
           </a:p>
@@ -18748,7 +18748,7 @@
         <p:spPr>
           <a:xfrm>
             <a:off x="8313420" y="2872859"/>
-            <a:ext cx="572810" cy="182880"/>
+            <a:ext cx="1312307" cy="182880"/>
           </a:xfrm>
           <a:prstGeom prst="rect">
             <a:avLst/>
@@ -18779,7 +18779,7 @@
                   </a:extLst>
                 </a:hlinkClick>
               </a:rPr>
-              <a:t>Actions</a:t>
+              <a:t>Action (alternative)</a:t>
             </a:r>
             <a:endParaRPr lang="en-US" sz="1140" dirty="0"/>
           </a:p>

</xml_diff>